<commit_message>
Add public supervisor profile pages and SEO metadata.
Each recognised supervisor gets a public profile page with photo, linked from the supervisors directory. Adds shared SEO helpers and structured data, updates robots and sitemap, and refreshes the workflow docs and presentation.

Co-authored-by: Cursor <cursoragent@cursor.com>
</commit_message>
<xml_diff>
--- a/docs/presentation/Research_ERP_Presentation.pptx
+++ b/docs/presentation/Research_ERP_Presentation.pptx
@@ -21,9 +21,10 @@
     <p:sldId id="269" r:id="rId15"/>
     <p:sldId id="270" r:id="rId16"/>
     <p:sldId id="271" r:id="rId17"/>
+    <p:sldId id="272" r:id="rId18"/>
   </p:sldIdLst>
   <p:notesMasterIdLst>
-    <p:notesMasterId r:id="rId18"/>
+    <p:notesMasterId r:id="rId19"/>
   </p:notesMasterIdLst>
   <p:sldSz cx="9144000" cy="5143500"/>
   <p:notesSz cx="5143500" cy="9144000"/>
@@ -1045,7 +1046,7 @@
           <a:p>
             <a:r>
               <a:rPr lang="en-US" dirty="0"/>
-              <a:t>The ERP keeps who did what and when. Files are in private storage and are never public.</a:t>
+              <a:t>The Supervisors page is generated on the server so that search engines can read every profile. Each supervisor has a page of their own.</a:t>
             </a:r>
             <a:endParaRPr lang="en-US" dirty="0"/>
           </a:p>
@@ -1133,7 +1134,7 @@
           <a:p>
             <a:r>
               <a:rPr lang="en-US" dirty="0"/>
-              <a:t>Close with the decisions needed: codes from the COE, mail provider, acceptance test and go-live.</a:t>
+              <a:t>The ERP keeps who did what and when. Files are in private storage and are never public.</a:t>
             </a:r>
             <a:endParaRPr lang="en-US" dirty="0"/>
           </a:p>
@@ -1157,6 +1158,94 @@
             <a:fld id="{F7021451-1387-4CA6-816F-3879F97B5CBC}" type="slidenum">
               <a:rPr lang="en-US"/>
               <a:t>16</a:t>
+            </a:fld>
+            <a:endParaRPr lang="en-US"/>
+          </a:p>
+        </p:txBody>
+      </p:sp>
+    </p:spTree>
+    <p:extLst>
+      <p:ext uri="{BB962C8B-B14F-4D97-AF65-F5344CB8AC3E}">
+        <p14:creationId xmlns:p14="http://schemas.microsoft.com/office/powerpoint/2010/main" val="1024086991"/>
+      </p:ext>
+    </p:extLst>
+  </p:cSld>
+  <p:clrMapOvr>
+    <a:masterClrMapping/>
+  </p:clrMapOvr>
+</p:notes>
+</file>
+
+<file path=ppt/notesSlides/notesSlide17.xml><?xml version="1.0" encoding="utf-8"?>
+<p:notes xmlns:a="http://schemas.openxmlformats.org/drawingml/2006/main" xmlns:r="http://schemas.openxmlformats.org/officeDocument/2006/relationships" xmlns:p="http://schemas.openxmlformats.org/presentationml/2006/main">
+  <p:cSld>
+    <p:spTree>
+      <p:nvGrpSpPr>
+        <p:cNvPr id="1" name=""/>
+        <p:cNvGrpSpPr/>
+        <p:nvPr/>
+      </p:nvGrpSpPr>
+      <p:grpSpPr>
+        <a:xfrm>
+          <a:off x="0" y="0"/>
+          <a:ext cx="0" cy="0"/>
+          <a:chOff x="0" y="0"/>
+          <a:chExt cx="0" cy="0"/>
+        </a:xfrm>
+      </p:grpSpPr>
+      <p:sp>
+        <p:nvSpPr>
+          <p:cNvPr id="2" name="Slide Image Placeholder 1"/>
+          <p:cNvSpPr>
+            <a:spLocks noGrp="1" noRot="1" noChangeAspect="1"/>
+          </p:cNvSpPr>
+          <p:nvPr>
+            <p:ph type="sldImg"/>
+          </p:nvPr>
+        </p:nvSpPr>
+        <p:spPr/>
+      </p:sp>
+      <p:sp>
+        <p:nvSpPr>
+          <p:cNvPr id="3" name="Notes Placeholder 2"/>
+          <p:cNvSpPr>
+            <a:spLocks noGrp="1"/>
+          </p:cNvSpPr>
+          <p:nvPr>
+            <p:ph type="body" idx="1"/>
+          </p:nvPr>
+        </p:nvSpPr>
+        <p:spPr/>
+        <p:txBody>
+          <a:bodyPr/>
+          <a:lstStyle/>
+          <a:p>
+            <a:r>
+              <a:rPr lang="en-US" dirty="0"/>
+              <a:t>Close with the decisions needed: codes from the COE, mail provider, acceptance test and go-live.</a:t>
+            </a:r>
+            <a:endParaRPr lang="en-US" dirty="0"/>
+          </a:p>
+        </p:txBody>
+      </p:sp>
+      <p:sp>
+        <p:nvSpPr>
+          <p:cNvPr id="4" name="Slide Number Placeholder 3"/>
+          <p:cNvSpPr>
+            <a:spLocks noGrp="1"/>
+          </p:cNvSpPr>
+          <p:nvPr>
+            <p:ph type="sldNum" sz="quarter" idx="10"/>
+          </p:nvPr>
+        </p:nvSpPr>
+        <p:spPr/>
+        <p:txBody>
+          <a:bodyPr/>
+          <a:lstStyle/>
+          <a:p>
+            <a:fld id="{F7021451-1387-4CA6-816F-3879F97B5CBC}" type="slidenum">
+              <a:rPr lang="en-US"/>
+              <a:t>17</a:t>
             </a:fld>
             <a:endParaRPr lang="en-US"/>
           </a:p>
@@ -4266,7 +4355,7 @@
                 <a:ea typeface="Calibri" pitchFamily="34" charset="-122"/>
                 <a:cs typeface="Calibri" pitchFamily="34" charset="-120"/>
               </a:rPr>
-              <a:t>Set-up</a:t>
+              <a:t>Subjects first</a:t>
             </a:r>
             <a:endParaRPr lang="en-US" sz="1400" dirty="0"/>
           </a:p>
@@ -4286,7 +4375,7 @@
                 <a:ea typeface="Calibri" pitchFamily="34" charset="-122"/>
                 <a:cs typeface="Calibri" pitchFamily="34" charset="-120"/>
               </a:rPr>
-              <a:t>Campuses, rooms, timetable, pass mark and grades</a:t>
+              <a:t>Admin adds subject code and title; registration cannot open without them</a:t>
             </a:r>
             <a:endParaRPr lang="en-US" sz="1400" dirty="0"/>
           </a:p>
@@ -4440,7 +4529,7 @@
                 <a:ea typeface="Calibri" pitchFamily="34" charset="-122"/>
                 <a:cs typeface="Calibri" pitchFamily="34" charset="-120"/>
               </a:rPr>
-              <a:t>Scholar picks the campus and pays the fee</a:t>
+              <a:t>Scholar picks listed subjects and a campus, and pays the fee</a:t>
             </a:r>
             <a:endParaRPr lang="en-US" sz="1400" dirty="0"/>
           </a:p>
@@ -4594,7 +4683,7 @@
                 <a:ea typeface="Calibri" pitchFamily="34" charset="-122"/>
                 <a:cs typeface="Calibri" pitchFamily="34" charset="-120"/>
               </a:rPr>
-              <a:t>Accounts approves; hall ticket follows only then</a:t>
+              <a:t>Accounts approves; the hall ticket follows only then</a:t>
             </a:r>
             <a:endParaRPr lang="en-US" sz="1400" dirty="0"/>
           </a:p>
@@ -4748,7 +4837,7 @@
                 <a:ea typeface="Calibri" pitchFamily="34" charset="-122"/>
                 <a:cs typeface="Calibri" pitchFamily="34" charset="-120"/>
               </a:rPr>
-              <a:t>One ticket per scholar with papers, room and seat</a:t>
+              <a:t>Papers, campus, room and seat; set-up of campuses and timetable</a:t>
             </a:r>
             <a:endParaRPr lang="en-US" sz="1400" dirty="0"/>
           </a:p>
@@ -6812,7 +6901,7 @@
                 <a:ea typeface="Cambria" pitchFamily="34" charset="-122"/>
                 <a:cs typeface="Cambria" pitchFamily="34" charset="-120"/>
               </a:rPr>
-              <a:t>Records, security and control</a:t>
+              <a:t>Public website and search visibility</a:t>
             </a:r>
             <a:endParaRPr lang="en-US" sz="2800" dirty="0"/>
           </a:p>
@@ -6881,7 +6970,7 @@
                 <a:ea typeface="Calibri" pitchFamily="34" charset="-122"/>
                 <a:cs typeface="Calibri" pitchFamily="34" charset="-120"/>
               </a:rPr>
-              <a:t>Role-based menus</a:t>
+              <a:t>Readable by search engines</a:t>
             </a:r>
             <a:endParaRPr lang="en-US" sz="1500" dirty="0"/>
           </a:p>
@@ -6901,7 +6990,7 @@
                 <a:ea typeface="Calibri" pitchFamily="34" charset="-122"/>
                 <a:cs typeface="Calibri" pitchFamily="34" charset="-120"/>
               </a:rPr>
-              <a:t>Each sign-in sees only its menus; the administrator grants sub-menu rights</a:t>
+              <a:t>Supervisor profiles are built on the server as plain pages, refreshed within minutes of an edit</a:t>
             </a:r>
             <a:endParaRPr lang="en-US" sz="1500" dirty="0"/>
           </a:p>
@@ -6970,7 +7059,7 @@
                 <a:ea typeface="Calibri" pitchFamily="34" charset="-122"/>
                 <a:cs typeface="Calibri" pitchFamily="34" charset="-120"/>
               </a:rPr>
-              <a:t>Audit trail</a:t>
+              <a:t>A page for each supervisor</a:t>
             </a:r>
             <a:endParaRPr lang="en-US" sz="1500" dirty="0"/>
           </a:p>
@@ -6990,7 +7079,7 @@
                 <a:ea typeface="Calibri" pitchFamily="34" charset="-122"/>
                 <a:cs typeface="Calibri" pitchFamily="34" charset="-120"/>
               </a:rPr>
-              <a:t>Decisions carry the name, date and time; registration numbers are logged</a:t>
+              <a:t>Own address, title and description, so a name search leads to the profile</a:t>
             </a:r>
             <a:endParaRPr lang="en-US" sz="1500" dirty="0"/>
           </a:p>
@@ -7059,7 +7148,7 @@
                 <a:ea typeface="Calibri" pitchFamily="34" charset="-122"/>
                 <a:cs typeface="Calibri" pitchFamily="34" charset="-120"/>
               </a:rPr>
-              <a:t>Private file storage</a:t>
+              <a:t>Structured data</a:t>
             </a:r>
             <a:endParaRPr lang="en-US" sz="1500" dirty="0"/>
           </a:p>
@@ -7079,7 +7168,7 @@
                 <a:ea typeface="Calibri" pitchFamily="34" charset="-122"/>
                 <a:cs typeface="Calibri" pitchFamily="34" charset="-120"/>
               </a:rPr>
-              <a:t>Documents in a private store; opened only after sign-in through short-lived links</a:t>
+              <a:t>University, website, supervisors, areas of research and Vidwan links described for search engines</a:t>
             </a:r>
             <a:endParaRPr lang="en-US" sz="1500" dirty="0"/>
           </a:p>
@@ -7148,7 +7237,7 @@
                 <a:ea typeface="Calibri" pitchFamily="34" charset="-122"/>
                 <a:cs typeface="Calibri" pitchFamily="34" charset="-120"/>
               </a:rPr>
-              <a:t>Backups</a:t>
+              <a:t>Sitemap and robots</a:t>
             </a:r>
             <a:endParaRPr lang="en-US" sz="1500" dirty="0"/>
           </a:p>
@@ -7168,7 +7257,7 @@
                 <a:ea typeface="Calibri" pitchFamily="34" charset="-122"/>
                 <a:cs typeface="Calibri" pitchFamily="34" charset="-120"/>
               </a:rPr>
-              <a:t>One command saves every table; another restores a saved copy</a:t>
+              <a:t>Public pages and supervisor profiles listed; portals and sign-in pages kept out of search</a:t>
             </a:r>
             <a:endParaRPr lang="en-US" sz="1500" dirty="0"/>
           </a:p>
@@ -7237,7 +7326,7 @@
                 <a:ea typeface="Calibri" pitchFamily="34" charset="-122"/>
                 <a:cs typeface="Calibri" pitchFamily="34" charset="-120"/>
               </a:rPr>
-              <a:t>Reopen a step</a:t>
+              <a:t>Sharing and images</a:t>
             </a:r>
             <a:endParaRPr lang="en-US" sz="1500" dirty="0"/>
           </a:p>
@@ -7257,7 +7346,7 @@
                 <a:ea typeface="Calibri" pitchFamily="34" charset="-122"/>
                 <a:cs typeface="Calibri" pitchFamily="34" charset="-120"/>
               </a:rPr>
-              <a:t>Reopening clears that step's work so it is redone in full</a:t>
+              <a:t>Preview cards for social sharing; photographs carry descriptive text</a:t>
             </a:r>
             <a:endParaRPr lang="en-US" sz="1500" dirty="0"/>
           </a:p>
@@ -7326,7 +7415,7 @@
                 <a:ea typeface="Calibri" pitchFamily="34" charset="-122"/>
                 <a:cs typeface="Calibri" pitchFamily="34" charset="-120"/>
               </a:rPr>
-              <a:t>Sample testing</a:t>
+              <a:t>Privacy kept</a:t>
             </a:r>
             <a:endParaRPr lang="en-US" sz="1500" dirty="0"/>
           </a:p>
@@ -7346,7 +7435,7 @@
                 <a:ea typeface="Calibri" pitchFamily="34" charset="-122"/>
                 <a:cs typeface="Calibri" pitchFamily="34" charset="-120"/>
               </a:rPr>
-              <a:t>Discard a test session and nothing is left behind</a:t>
+              <a:t>Only public profile fields are published; no sign-in e-mail</a:t>
             </a:r>
             <a:endParaRPr lang="en-US" sz="1500" dirty="0"/>
           </a:p>
@@ -7411,6 +7500,654 @@
 <file path=ppt/slides/slide16.xml><?xml version="1.0" encoding="utf-8"?>
 <p:sld xmlns:a="http://schemas.openxmlformats.org/drawingml/2006/main" xmlns:r="http://schemas.openxmlformats.org/officeDocument/2006/relationships" xmlns:p="http://schemas.openxmlformats.org/presentationml/2006/main">
   <p:cSld name="Slide 16">
+    <p:spTree>
+      <p:nvGrpSpPr>
+        <p:cNvPr id="1" name=""/>
+        <p:cNvGrpSpPr/>
+        <p:nvPr/>
+      </p:nvGrpSpPr>
+      <p:grpSpPr>
+        <a:xfrm>
+          <a:off x="0" y="0"/>
+          <a:ext cx="0" cy="0"/>
+          <a:chOff x="0" y="0"/>
+          <a:chExt cx="0" cy="0"/>
+        </a:xfrm>
+      </p:grpSpPr>
+      <p:sp>
+        <p:nvSpPr>
+          <p:cNvPr id="2" name="Text 1"/>
+          <p:cNvSpPr/>
+          <p:nvPr>
+            <p:ph idx="101" type="title" hasCustomPrompt="1"/>
+          </p:nvPr>
+        </p:nvSpPr>
+        <p:spPr>
+          <a:xfrm>
+            <a:off x="457200" y="274320"/>
+            <a:ext cx="8229600" cy="685800"/>
+          </a:xfrm>
+          <a:prstGeom prst="rect">
+            <a:avLst/>
+          </a:prstGeom>
+          <a:noFill/>
+          <a:ln/>
+        </p:spPr>
+        <p:txBody>
+          <a:bodyPr wrap="square" lIns="0" tIns="0" rIns="0" bIns="0" rtlCol="0" anchor="ctr"/>
+          <a:lstStyle/>
+          <a:p>
+            <a:pPr indent="0" marL="0">
+              <a:buNone/>
+            </a:pPr>
+            <a:r>
+              <a:rPr lang="en-US" sz="2800" b="1" dirty="0">
+                <a:solidFill>
+                  <a:srgbClr val="6B1E2E"/>
+                </a:solidFill>
+                <a:latin typeface="Cambria" pitchFamily="34" charset="0"/>
+                <a:ea typeface="Cambria" pitchFamily="34" charset="-122"/>
+                <a:cs typeface="Cambria" pitchFamily="34" charset="-120"/>
+              </a:rPr>
+              <a:t>Records, security and control</a:t>
+            </a:r>
+            <a:endParaRPr lang="en-US" sz="2800" dirty="0"/>
+          </a:p>
+        </p:txBody>
+      </p:sp>
+      <p:sp>
+        <p:nvSpPr>
+          <p:cNvPr id="4" name="Shape 1"/>
+          <p:cNvSpPr/>
+          <p:nvPr/>
+        </p:nvSpPr>
+        <p:spPr>
+          <a:xfrm>
+            <a:off x="457200" y="1234440"/>
+            <a:ext cx="2651760" cy="1600200"/>
+          </a:xfrm>
+          <a:prstGeom prst="roundRect">
+            <a:avLst>
+              <a:gd name="adj" fmla="val 4571"/>
+            </a:avLst>
+          </a:prstGeom>
+          <a:solidFill>
+            <a:srgbClr val="F4EEF0"/>
+          </a:solidFill>
+          <a:ln w="9525">
+            <a:solidFill>
+              <a:srgbClr val="D9CDD1"/>
+            </a:solidFill>
+            <a:prstDash val="solid"/>
+          </a:ln>
+        </p:spPr>
+      </p:sp>
+      <p:sp>
+        <p:nvSpPr>
+          <p:cNvPr id="5" name="Text 2"/>
+          <p:cNvSpPr txBox="1"/>
+          <p:nvPr/>
+        </p:nvSpPr>
+        <p:spPr>
+          <a:xfrm>
+            <a:off x="566928" y="1289304"/>
+            <a:ext cx="2432304" cy="1490472"/>
+          </a:xfrm>
+          <a:prstGeom prst="rect">
+            <a:avLst/>
+          </a:prstGeom>
+          <a:noFill/>
+          <a:ln/>
+        </p:spPr>
+        <p:txBody>
+          <a:bodyPr wrap="square" lIns="0" tIns="0" rIns="0" bIns="0" rtlCol="0" anchor="t"/>
+          <a:lstStyle/>
+          <a:p>
+            <a:pPr indent="0" marL="0">
+              <a:spcAft>
+                <a:spcPts val="200"/>
+              </a:spcAft>
+              <a:buNone/>
+            </a:pPr>
+            <a:r>
+              <a:rPr lang="en-US" sz="1500" b="1" dirty="0">
+                <a:solidFill>
+                  <a:srgbClr val="6B1E2E"/>
+                </a:solidFill>
+                <a:latin typeface="Calibri" pitchFamily="34" charset="0"/>
+                <a:ea typeface="Calibri" pitchFamily="34" charset="-122"/>
+                <a:cs typeface="Calibri" pitchFamily="34" charset="-120"/>
+              </a:rPr>
+              <a:t>Role-based menus</a:t>
+            </a:r>
+            <a:endParaRPr lang="en-US" sz="1500" dirty="0"/>
+          </a:p>
+          <a:p>
+            <a:pPr indent="0" marL="0">
+              <a:spcAft>
+                <a:spcPts val="200"/>
+              </a:spcAft>
+              <a:buNone/>
+            </a:pPr>
+            <a:r>
+              <a:rPr lang="en-US" sz="1300" dirty="0">
+                <a:solidFill>
+                  <a:srgbClr val="2A2A33"/>
+                </a:solidFill>
+                <a:latin typeface="Calibri" pitchFamily="34" charset="0"/>
+                <a:ea typeface="Calibri" pitchFamily="34" charset="-122"/>
+                <a:cs typeface="Calibri" pitchFamily="34" charset="-120"/>
+              </a:rPr>
+              <a:t>Each sign-in sees only its menus; the administrator grants sub-menu rights</a:t>
+            </a:r>
+            <a:endParaRPr lang="en-US" sz="1500" dirty="0"/>
+          </a:p>
+        </p:txBody>
+      </p:sp>
+      <p:sp>
+        <p:nvSpPr>
+          <p:cNvPr id="6" name="Shape 3"/>
+          <p:cNvSpPr/>
+          <p:nvPr/>
+        </p:nvSpPr>
+        <p:spPr>
+          <a:xfrm>
+            <a:off x="3246120" y="1234440"/>
+            <a:ext cx="2651760" cy="1600200"/>
+          </a:xfrm>
+          <a:prstGeom prst="roundRect">
+            <a:avLst>
+              <a:gd name="adj" fmla="val 4571"/>
+            </a:avLst>
+          </a:prstGeom>
+          <a:solidFill>
+            <a:srgbClr val="F4EEF0"/>
+          </a:solidFill>
+          <a:ln w="9525">
+            <a:solidFill>
+              <a:srgbClr val="D9CDD1"/>
+            </a:solidFill>
+            <a:prstDash val="solid"/>
+          </a:ln>
+        </p:spPr>
+      </p:sp>
+      <p:sp>
+        <p:nvSpPr>
+          <p:cNvPr id="7" name="Text 4"/>
+          <p:cNvSpPr txBox="1"/>
+          <p:nvPr/>
+        </p:nvSpPr>
+        <p:spPr>
+          <a:xfrm>
+            <a:off x="3355848" y="1289304"/>
+            <a:ext cx="2432304" cy="1490472"/>
+          </a:xfrm>
+          <a:prstGeom prst="rect">
+            <a:avLst/>
+          </a:prstGeom>
+          <a:noFill/>
+          <a:ln/>
+        </p:spPr>
+        <p:txBody>
+          <a:bodyPr wrap="square" lIns="0" tIns="0" rIns="0" bIns="0" rtlCol="0" anchor="t"/>
+          <a:lstStyle/>
+          <a:p>
+            <a:pPr indent="0" marL="0">
+              <a:spcAft>
+                <a:spcPts val="200"/>
+              </a:spcAft>
+              <a:buNone/>
+            </a:pPr>
+            <a:r>
+              <a:rPr lang="en-US" sz="1500" b="1" dirty="0">
+                <a:solidFill>
+                  <a:srgbClr val="6B1E2E"/>
+                </a:solidFill>
+                <a:latin typeface="Calibri" pitchFamily="34" charset="0"/>
+                <a:ea typeface="Calibri" pitchFamily="34" charset="-122"/>
+                <a:cs typeface="Calibri" pitchFamily="34" charset="-120"/>
+              </a:rPr>
+              <a:t>Audit trail</a:t>
+            </a:r>
+            <a:endParaRPr lang="en-US" sz="1500" dirty="0"/>
+          </a:p>
+          <a:p>
+            <a:pPr indent="0" marL="0">
+              <a:spcAft>
+                <a:spcPts val="200"/>
+              </a:spcAft>
+              <a:buNone/>
+            </a:pPr>
+            <a:r>
+              <a:rPr lang="en-US" sz="1300" dirty="0">
+                <a:solidFill>
+                  <a:srgbClr val="2A2A33"/>
+                </a:solidFill>
+                <a:latin typeface="Calibri" pitchFamily="34" charset="0"/>
+                <a:ea typeface="Calibri" pitchFamily="34" charset="-122"/>
+                <a:cs typeface="Calibri" pitchFamily="34" charset="-120"/>
+              </a:rPr>
+              <a:t>Decisions carry the name, date and time; registration numbers are logged</a:t>
+            </a:r>
+            <a:endParaRPr lang="en-US" sz="1500" dirty="0"/>
+          </a:p>
+        </p:txBody>
+      </p:sp>
+      <p:sp>
+        <p:nvSpPr>
+          <p:cNvPr id="8" name="Shape 5"/>
+          <p:cNvSpPr/>
+          <p:nvPr/>
+        </p:nvSpPr>
+        <p:spPr>
+          <a:xfrm>
+            <a:off x="6035040" y="1234440"/>
+            <a:ext cx="2651760" cy="1600200"/>
+          </a:xfrm>
+          <a:prstGeom prst="roundRect">
+            <a:avLst>
+              <a:gd name="adj" fmla="val 4571"/>
+            </a:avLst>
+          </a:prstGeom>
+          <a:solidFill>
+            <a:srgbClr val="F4EEF0"/>
+          </a:solidFill>
+          <a:ln w="9525">
+            <a:solidFill>
+              <a:srgbClr val="D9CDD1"/>
+            </a:solidFill>
+            <a:prstDash val="solid"/>
+          </a:ln>
+        </p:spPr>
+      </p:sp>
+      <p:sp>
+        <p:nvSpPr>
+          <p:cNvPr id="9" name="Text 6"/>
+          <p:cNvSpPr txBox="1"/>
+          <p:nvPr/>
+        </p:nvSpPr>
+        <p:spPr>
+          <a:xfrm>
+            <a:off x="6144768" y="1289304"/>
+            <a:ext cx="2432304" cy="1490472"/>
+          </a:xfrm>
+          <a:prstGeom prst="rect">
+            <a:avLst/>
+          </a:prstGeom>
+          <a:noFill/>
+          <a:ln/>
+        </p:spPr>
+        <p:txBody>
+          <a:bodyPr wrap="square" lIns="0" tIns="0" rIns="0" bIns="0" rtlCol="0" anchor="t"/>
+          <a:lstStyle/>
+          <a:p>
+            <a:pPr indent="0" marL="0">
+              <a:spcAft>
+                <a:spcPts val="200"/>
+              </a:spcAft>
+              <a:buNone/>
+            </a:pPr>
+            <a:r>
+              <a:rPr lang="en-US" sz="1500" b="1" dirty="0">
+                <a:solidFill>
+                  <a:srgbClr val="6B1E2E"/>
+                </a:solidFill>
+                <a:latin typeface="Calibri" pitchFamily="34" charset="0"/>
+                <a:ea typeface="Calibri" pitchFamily="34" charset="-122"/>
+                <a:cs typeface="Calibri" pitchFamily="34" charset="-120"/>
+              </a:rPr>
+              <a:t>Private file storage</a:t>
+            </a:r>
+            <a:endParaRPr lang="en-US" sz="1500" dirty="0"/>
+          </a:p>
+          <a:p>
+            <a:pPr indent="0" marL="0">
+              <a:spcAft>
+                <a:spcPts val="200"/>
+              </a:spcAft>
+              <a:buNone/>
+            </a:pPr>
+            <a:r>
+              <a:rPr lang="en-US" sz="1300" dirty="0">
+                <a:solidFill>
+                  <a:srgbClr val="2A2A33"/>
+                </a:solidFill>
+                <a:latin typeface="Calibri" pitchFamily="34" charset="0"/>
+                <a:ea typeface="Calibri" pitchFamily="34" charset="-122"/>
+                <a:cs typeface="Calibri" pitchFamily="34" charset="-120"/>
+              </a:rPr>
+              <a:t>Documents in a private store; opened only after sign-in through short-lived links</a:t>
+            </a:r>
+            <a:endParaRPr lang="en-US" sz="1500" dirty="0"/>
+          </a:p>
+        </p:txBody>
+      </p:sp>
+      <p:sp>
+        <p:nvSpPr>
+          <p:cNvPr id="10" name="Shape 7"/>
+          <p:cNvSpPr/>
+          <p:nvPr/>
+        </p:nvSpPr>
+        <p:spPr>
+          <a:xfrm>
+            <a:off x="457200" y="2971800"/>
+            <a:ext cx="2651760" cy="1600200"/>
+          </a:xfrm>
+          <a:prstGeom prst="roundRect">
+            <a:avLst>
+              <a:gd name="adj" fmla="val 4571"/>
+            </a:avLst>
+          </a:prstGeom>
+          <a:solidFill>
+            <a:srgbClr val="F4EEF0"/>
+          </a:solidFill>
+          <a:ln w="9525">
+            <a:solidFill>
+              <a:srgbClr val="D9CDD1"/>
+            </a:solidFill>
+            <a:prstDash val="solid"/>
+          </a:ln>
+        </p:spPr>
+      </p:sp>
+      <p:sp>
+        <p:nvSpPr>
+          <p:cNvPr id="11" name="Text 8"/>
+          <p:cNvSpPr txBox="1"/>
+          <p:nvPr/>
+        </p:nvSpPr>
+        <p:spPr>
+          <a:xfrm>
+            <a:off x="566928" y="3026664"/>
+            <a:ext cx="2432304" cy="1490472"/>
+          </a:xfrm>
+          <a:prstGeom prst="rect">
+            <a:avLst/>
+          </a:prstGeom>
+          <a:noFill/>
+          <a:ln/>
+        </p:spPr>
+        <p:txBody>
+          <a:bodyPr wrap="square" lIns="0" tIns="0" rIns="0" bIns="0" rtlCol="0" anchor="t"/>
+          <a:lstStyle/>
+          <a:p>
+            <a:pPr indent="0" marL="0">
+              <a:spcAft>
+                <a:spcPts val="200"/>
+              </a:spcAft>
+              <a:buNone/>
+            </a:pPr>
+            <a:r>
+              <a:rPr lang="en-US" sz="1500" b="1" dirty="0">
+                <a:solidFill>
+                  <a:srgbClr val="6B1E2E"/>
+                </a:solidFill>
+                <a:latin typeface="Calibri" pitchFamily="34" charset="0"/>
+                <a:ea typeface="Calibri" pitchFamily="34" charset="-122"/>
+                <a:cs typeface="Calibri" pitchFamily="34" charset="-120"/>
+              </a:rPr>
+              <a:t>Backups</a:t>
+            </a:r>
+            <a:endParaRPr lang="en-US" sz="1500" dirty="0"/>
+          </a:p>
+          <a:p>
+            <a:pPr indent="0" marL="0">
+              <a:spcAft>
+                <a:spcPts val="200"/>
+              </a:spcAft>
+              <a:buNone/>
+            </a:pPr>
+            <a:r>
+              <a:rPr lang="en-US" sz="1300" dirty="0">
+                <a:solidFill>
+                  <a:srgbClr val="2A2A33"/>
+                </a:solidFill>
+                <a:latin typeface="Calibri" pitchFamily="34" charset="0"/>
+                <a:ea typeface="Calibri" pitchFamily="34" charset="-122"/>
+                <a:cs typeface="Calibri" pitchFamily="34" charset="-120"/>
+              </a:rPr>
+              <a:t>One command saves every table; another restores a saved copy</a:t>
+            </a:r>
+            <a:endParaRPr lang="en-US" sz="1500" dirty="0"/>
+          </a:p>
+        </p:txBody>
+      </p:sp>
+      <p:sp>
+        <p:nvSpPr>
+          <p:cNvPr id="12" name="Shape 9"/>
+          <p:cNvSpPr/>
+          <p:nvPr/>
+        </p:nvSpPr>
+        <p:spPr>
+          <a:xfrm>
+            <a:off x="3246120" y="2971800"/>
+            <a:ext cx="2651760" cy="1600200"/>
+          </a:xfrm>
+          <a:prstGeom prst="roundRect">
+            <a:avLst>
+              <a:gd name="adj" fmla="val 4571"/>
+            </a:avLst>
+          </a:prstGeom>
+          <a:solidFill>
+            <a:srgbClr val="F4EEF0"/>
+          </a:solidFill>
+          <a:ln w="9525">
+            <a:solidFill>
+              <a:srgbClr val="D9CDD1"/>
+            </a:solidFill>
+            <a:prstDash val="solid"/>
+          </a:ln>
+        </p:spPr>
+      </p:sp>
+      <p:sp>
+        <p:nvSpPr>
+          <p:cNvPr id="13" name="Text 10"/>
+          <p:cNvSpPr txBox="1"/>
+          <p:nvPr/>
+        </p:nvSpPr>
+        <p:spPr>
+          <a:xfrm>
+            <a:off x="3355848" y="3026664"/>
+            <a:ext cx="2432304" cy="1490472"/>
+          </a:xfrm>
+          <a:prstGeom prst="rect">
+            <a:avLst/>
+          </a:prstGeom>
+          <a:noFill/>
+          <a:ln/>
+        </p:spPr>
+        <p:txBody>
+          <a:bodyPr wrap="square" lIns="0" tIns="0" rIns="0" bIns="0" rtlCol="0" anchor="t"/>
+          <a:lstStyle/>
+          <a:p>
+            <a:pPr indent="0" marL="0">
+              <a:spcAft>
+                <a:spcPts val="200"/>
+              </a:spcAft>
+              <a:buNone/>
+            </a:pPr>
+            <a:r>
+              <a:rPr lang="en-US" sz="1500" b="1" dirty="0">
+                <a:solidFill>
+                  <a:srgbClr val="6B1E2E"/>
+                </a:solidFill>
+                <a:latin typeface="Calibri" pitchFamily="34" charset="0"/>
+                <a:ea typeface="Calibri" pitchFamily="34" charset="-122"/>
+                <a:cs typeface="Calibri" pitchFamily="34" charset="-120"/>
+              </a:rPr>
+              <a:t>Reopen a step</a:t>
+            </a:r>
+            <a:endParaRPr lang="en-US" sz="1500" dirty="0"/>
+          </a:p>
+          <a:p>
+            <a:pPr indent="0" marL="0">
+              <a:spcAft>
+                <a:spcPts val="200"/>
+              </a:spcAft>
+              <a:buNone/>
+            </a:pPr>
+            <a:r>
+              <a:rPr lang="en-US" sz="1300" dirty="0">
+                <a:solidFill>
+                  <a:srgbClr val="2A2A33"/>
+                </a:solidFill>
+                <a:latin typeface="Calibri" pitchFamily="34" charset="0"/>
+                <a:ea typeface="Calibri" pitchFamily="34" charset="-122"/>
+                <a:cs typeface="Calibri" pitchFamily="34" charset="-120"/>
+              </a:rPr>
+              <a:t>Reopening clears that step's work so it is redone in full</a:t>
+            </a:r>
+            <a:endParaRPr lang="en-US" sz="1500" dirty="0"/>
+          </a:p>
+        </p:txBody>
+      </p:sp>
+      <p:sp>
+        <p:nvSpPr>
+          <p:cNvPr id="14" name="Shape 11"/>
+          <p:cNvSpPr/>
+          <p:nvPr/>
+        </p:nvSpPr>
+        <p:spPr>
+          <a:xfrm>
+            <a:off x="6035040" y="2971800"/>
+            <a:ext cx="2651760" cy="1600200"/>
+          </a:xfrm>
+          <a:prstGeom prst="roundRect">
+            <a:avLst>
+              <a:gd name="adj" fmla="val 4571"/>
+            </a:avLst>
+          </a:prstGeom>
+          <a:solidFill>
+            <a:srgbClr val="F4EEF0"/>
+          </a:solidFill>
+          <a:ln w="9525">
+            <a:solidFill>
+              <a:srgbClr val="D9CDD1"/>
+            </a:solidFill>
+            <a:prstDash val="solid"/>
+          </a:ln>
+        </p:spPr>
+      </p:sp>
+      <p:sp>
+        <p:nvSpPr>
+          <p:cNvPr id="15" name="Text 12"/>
+          <p:cNvSpPr txBox="1"/>
+          <p:nvPr/>
+        </p:nvSpPr>
+        <p:spPr>
+          <a:xfrm>
+            <a:off x="6144768" y="3026664"/>
+            <a:ext cx="2432304" cy="1490472"/>
+          </a:xfrm>
+          <a:prstGeom prst="rect">
+            <a:avLst/>
+          </a:prstGeom>
+          <a:noFill/>
+          <a:ln/>
+        </p:spPr>
+        <p:txBody>
+          <a:bodyPr wrap="square" lIns="0" tIns="0" rIns="0" bIns="0" rtlCol="0" anchor="t"/>
+          <a:lstStyle/>
+          <a:p>
+            <a:pPr indent="0" marL="0">
+              <a:spcAft>
+                <a:spcPts val="200"/>
+              </a:spcAft>
+              <a:buNone/>
+            </a:pPr>
+            <a:r>
+              <a:rPr lang="en-US" sz="1500" b="1" dirty="0">
+                <a:solidFill>
+                  <a:srgbClr val="6B1E2E"/>
+                </a:solidFill>
+                <a:latin typeface="Calibri" pitchFamily="34" charset="0"/>
+                <a:ea typeface="Calibri" pitchFamily="34" charset="-122"/>
+                <a:cs typeface="Calibri" pitchFamily="34" charset="-120"/>
+              </a:rPr>
+              <a:t>Sample testing</a:t>
+            </a:r>
+            <a:endParaRPr lang="en-US" sz="1500" dirty="0"/>
+          </a:p>
+          <a:p>
+            <a:pPr indent="0" marL="0">
+              <a:spcAft>
+                <a:spcPts val="200"/>
+              </a:spcAft>
+              <a:buNone/>
+            </a:pPr>
+            <a:r>
+              <a:rPr lang="en-US" sz="1300" dirty="0">
+                <a:solidFill>
+                  <a:srgbClr val="2A2A33"/>
+                </a:solidFill>
+                <a:latin typeface="Calibri" pitchFamily="34" charset="0"/>
+                <a:ea typeface="Calibri" pitchFamily="34" charset="-122"/>
+                <a:cs typeface="Calibri" pitchFamily="34" charset="-120"/>
+              </a:rPr>
+              <a:t>Discard a test session and nothing is left behind</a:t>
+            </a:r>
+            <a:endParaRPr lang="en-US" sz="1500" dirty="0"/>
+          </a:p>
+        </p:txBody>
+      </p:sp>
+      <p:sp>
+        <p:nvSpPr>
+          <p:cNvPr id="25" name="Slide Number Placeholder 0"/>
+          <p:cNvSpPr>
+            <a:spLocks noGrp="1"/>
+          </p:cNvSpPr>
+          <p:nvPr>
+            <p:ph type="sldNum" sz="quarter" idx="4294967295"/>
+          </p:nvPr>
+        </p:nvSpPr>
+        <p:spPr>
+          <a:xfrm>
+            <a:off x="8229600" y="4800600"/>
+            <a:ext cx="457200" cy="228600"/>
+          </a:xfrm>
+          <a:prstGeom prst="rect">
+            <a:avLst/>
+          </a:prstGeom>
+          <a:extLst>
+            <a:ext uri="{C572A759-6A51-4108-AA02-DFA0A04FC94B}">
+              <ma14:wrappingTextBoxFlag xmlns:ma14="http://schemas.microsoft.com/office/mac/drawingml/2011/main" val="0"/>
+            </a:ext>
+          </a:extLst>
+        </p:spPr>
+        <p:txBody>
+          <a:bodyPr/>
+          <a:lstStyle>
+            <a:lvl1pPr>
+              <a:defRPr sz="1000">
+                <a:solidFill>
+                  <a:srgbClr val="8A8A94"/>
+                </a:solidFill>
+                <a:latin typeface="Calibri"/>
+                <a:ea typeface="Calibri"/>
+                <a:cs typeface="Calibri"/>
+              </a:defRPr>
+            </a:lvl1pPr>
+          </a:lstStyle>
+          <a:p>
+            <a:pPr algn="l"/>
+            <a:fld id="{F7021451-1387-4CA6-816F-3879F97B5CBC}" type="slidenum">
+              <a:rPr b="0" lang="en-US"/>
+              <a:t>16</a:t>
+            </a:fld>
+            <a:endParaRPr lang="en-US"/>
+          </a:p>
+        </p:txBody>
+      </p:sp>
+    </p:spTree>
+  </p:cSld>
+  <p:clrMapOvr>
+    <a:masterClrMapping/>
+  </p:clrMapOvr>
+</p:sld>
+</file>
+
+<file path=ppt/slides/slide17.xml><?xml version="1.0" encoding="utf-8"?>
+<p:sld xmlns:a="http://schemas.openxmlformats.org/drawingml/2006/main" xmlns:r="http://schemas.openxmlformats.org/officeDocument/2006/relationships" xmlns:p="http://schemas.openxmlformats.org/presentationml/2006/main">
+  <p:cSld name="Slide 17">
     <p:spTree>
       <p:nvGrpSpPr>
         <p:cNvPr id="1" name=""/>

</xml_diff>